<commit_message>
Remove validation scripts and associated resources for presentation deck; delete GIFs and icons used in visuals.
</commit_message>
<xml_diff>
--- a/presentation-deck-v3.pptx
+++ b/presentation-deck-v3.pptx
@@ -381,6 +381,7 @@
     </c:plotArea>
     <c:legend>
       <c:legendPos val="b"/>
+      <c:layout/>
       <c:overlay val="0"/>
       <c:txPr>
         <a:bodyPr/>
@@ -5802,7 +5803,9 @@
             <a:avLst/>
           </a:prstGeom>
           <a:solidFill>
-            <a:srgbClr val="63E6BE"/>
+            <a:schemeClr val="bg2">
+              <a:lumMod val="25000"/>
+            </a:schemeClr>
           </a:solidFill>
           <a:ln>
             <a:noFill/>
@@ -5946,7 +5949,7 @@
         </p:nvSpPr>
         <p:spPr>
           <a:xfrm>
-            <a:off x="1371600" y="5806440"/>
+            <a:off x="1371600" y="6086358"/>
             <a:ext cx="9445752" cy="502920"/>
           </a:xfrm>
           <a:prstGeom prst="rect">
@@ -5972,6 +5975,7 @@
               </a:defRPr>
             </a:pPr>
             <a:r>
+              <a:rPr dirty="0"/>
               <a:t>Cross-border student finance · powered by AI</a:t>
             </a:r>
           </a:p>

</xml_diff>